<commit_message>
docs(ppt): release download link on closing slide; v1.0.61 chips
Co-Authored-By: Claude Fable 5 <noreply@anthropic.com>
</commit_message>
<xml_diff>
--- a/docs/ppt/ViitorXPC_Feature_Guide.pptx
+++ b/docs/ppt/ViitorXPC_Feature_Guide.pptx
@@ -3066,7 +3066,7 @@
                 <a:ea typeface="Arial" pitchFamily="34" charset="-122"/>
                 <a:cs typeface="Arial" pitchFamily="34" charset="-120"/>
               </a:rPr>
-              <a:t>v1.0.56</a:t>
+              <a:t>v1.0.61</a:t>
             </a:r>
             <a:endParaRPr lang="en-US" sz="1400" dirty="0"/>
           </a:p>
@@ -12561,9 +12561,130 @@
                 <a:ea typeface="Arial" pitchFamily="34" charset="-122"/>
                 <a:cs typeface="Arial" pitchFamily="34" charset="-120"/>
               </a:rPr>
-              <a:t>v1.0.56</a:t>
+              <a:t>v1.0.61</a:t>
             </a:r>
             <a:endParaRPr lang="en-US" sz="1400" dirty="0"/>
+          </a:p>
+        </p:txBody>
+      </p:sp>
+      <p:sp>
+        <p:nvSpPr>
+          <p:cNvPr id="7" name="Shape 5"/>
+          <p:cNvSpPr/>
+          <p:nvPr/>
+        </p:nvSpPr>
+        <p:spPr>
+          <a:xfrm>
+            <a:off x="2240280" y="4663440"/>
+            <a:ext cx="3291840" cy="457200"/>
+          </a:xfrm>
+          <a:prstGeom prst="roundRect">
+            <a:avLst>
+              <a:gd name="adj" fmla="val 50000"/>
+            </a:avLst>
+          </a:prstGeom>
+          <a:solidFill>
+            <a:srgbClr val="35D0C4"/>
+          </a:solidFill>
+          <a:ln/>
+          <a:effectLst>
+            <a:outerShdw sx="100000" sy="100000" kx="0" ky="0" algn="bl" rotWithShape="0" blurRad="114300" dist="38100" dir="5400000">
+              <a:srgbClr val="000000">
+                <a:alpha val="45000"/>
+              </a:srgbClr>
+            </a:outerShdw>
+          </a:effectLst>
+        </p:spPr>
+      </p:sp>
+      <p:sp>
+        <p:nvSpPr>
+          <p:cNvPr id="8" name="Text 6"/>
+          <p:cNvSpPr/>
+          <p:nvPr/>
+        </p:nvSpPr>
+        <p:spPr>
+          <a:xfrm>
+            <a:off x="2240280" y="4663440"/>
+            <a:ext cx="3291840" cy="457200"/>
+          </a:xfrm>
+          <a:prstGeom prst="rect">
+            <a:avLst/>
+          </a:prstGeom>
+          <a:noFill/>
+          <a:ln/>
+        </p:spPr>
+        <p:txBody>
+          <a:bodyPr wrap="square" lIns="0" tIns="0" rIns="0" bIns="0" rtlCol="0" anchor="ctr"/>
+          <a:lstStyle/>
+          <a:p>
+            <a:pPr algn="ctr" indent="0" marL="0">
+              <a:buNone/>
+            </a:pPr>
+            <a:r>
+              <a:rPr lang="en-US" sz="1350" b="1" u="sng" dirty="0">
+                <a:solidFill>
+                  <a:srgbClr val="0B1120"/>
+                </a:solidFill>
+                <a:latin typeface="Arial" pitchFamily="34" charset="0"/>
+                <a:ea typeface="Arial" pitchFamily="34" charset="-122"/>
+                <a:cs typeface="Arial" pitchFamily="34" charset="-120"/>
+                <a:hlinkClick r:id="rId1" invalidUrl="" action="" tgtFrame="" tooltip="ViitorX PointCloud Viewer 1.0.61 - GitHub release" history="1" highlightClick="0" endSnd="0">
+                  <a:extLst>
+                    <a:ext uri="{A12FA001-AC4F-418D-AE19-62706E023703}">
+                      <ahyp:hlinkClr xmlns:ahyp="http://schemas.microsoft.com/office/drawing/2018/hyperlinkcolor" val="tx"/>
+                    </a:ext>
+                  </a:extLst>
+                </a:hlinkClick>
+              </a:rPr>
+              <a:t>Download the compiled package</a:t>
+            </a:r>
+            <a:endParaRPr lang="en-US" sz="1350" dirty="0"/>
+          </a:p>
+        </p:txBody>
+      </p:sp>
+      <p:sp>
+        <p:nvSpPr>
+          <p:cNvPr id="9" name="Text 7"/>
+          <p:cNvSpPr/>
+          <p:nvPr/>
+        </p:nvSpPr>
+        <p:spPr>
+          <a:xfrm>
+            <a:off x="640080" y="5349240"/>
+            <a:ext cx="8778240" cy="320040"/>
+          </a:xfrm>
+          <a:prstGeom prst="rect">
+            <a:avLst/>
+          </a:prstGeom>
+          <a:noFill/>
+          <a:ln/>
+        </p:spPr>
+        <p:txBody>
+          <a:bodyPr wrap="square" lIns="0" tIns="0" rIns="0" bIns="0" rtlCol="0" anchor="ctr"/>
+          <a:lstStyle/>
+          <a:p>
+            <a:pPr indent="0" marL="0">
+              <a:buNone/>
+            </a:pPr>
+            <a:r>
+              <a:rPr lang="en-US" sz="1200" u="sng" dirty="0">
+                <a:solidFill>
+                  <a:srgbClr val="93A1B5"/>
+                </a:solidFill>
+                <a:latin typeface="Arial" pitchFamily="34" charset="0"/>
+                <a:ea typeface="Arial" pitchFamily="34" charset="-122"/>
+                <a:cs typeface="Arial" pitchFamily="34" charset="-120"/>
+                <a:hlinkClick r:id="rId2" invalidUrl="" action="" tgtFrame="" tooltip="" history="1" highlightClick="0" endSnd="0">
+                  <a:extLst>
+                    <a:ext uri="{A12FA001-AC4F-418D-AE19-62706E023703}">
+                      <ahyp:hlinkClr xmlns:ahyp="http://schemas.microsoft.com/office/drawing/2018/hyperlinkcolor" val="tx"/>
+                    </a:ext>
+                  </a:extLst>
+                </a:hlinkClick>
+              </a:rPr>
+              <a:t>https://github.com/vinayak-vc/ViitorX-PointCloud-Viewer/releases/tag/1.0.61</a:t>
+            </a:r>
+            <a:endParaRPr lang="en-US" sz="1200" dirty="0"/>
           </a:p>
         </p:txBody>
       </p:sp>

</xml_diff>